<commit_message>
docs: thang lam pp 08082026
</commit_message>
<xml_diff>
--- a/docs/3. Mau bao cao.pptx
+++ b/docs/3. Mau bao cao.pptx
@@ -3014,7 +3014,7 @@
         <a:spcBef>
           <a:spcPts val="1000"/>
         </a:spcBef>
-        <a:buFont typeface="Arial" panose="020B0704020202020204" pitchFamily="34" charset="0"/>
+        <a:buFont typeface="Arial" panose="020B0604020202020204" pitchFamily="34" charset="0"/>
         <a:buChar char="•"/>
         <a:defRPr sz="2800" kern="1200">
           <a:solidFill>
@@ -3032,7 +3032,7 @@
         <a:spcBef>
           <a:spcPts val="500"/>
         </a:spcBef>
-        <a:buFont typeface="Arial" panose="020B0704020202020204" pitchFamily="34" charset="0"/>
+        <a:buFont typeface="Arial" panose="020B0604020202020204" pitchFamily="34" charset="0"/>
         <a:buChar char="•"/>
         <a:defRPr sz="2400" kern="1200">
           <a:solidFill>
@@ -3050,7 +3050,7 @@
         <a:spcBef>
           <a:spcPts val="500"/>
         </a:spcBef>
-        <a:buFont typeface="Arial" panose="020B0704020202020204" pitchFamily="34" charset="0"/>
+        <a:buFont typeface="Arial" panose="020B0604020202020204" pitchFamily="34" charset="0"/>
         <a:buChar char="•"/>
         <a:defRPr sz="2000" kern="1200">
           <a:solidFill>
@@ -3068,7 +3068,7 @@
         <a:spcBef>
           <a:spcPts val="500"/>
         </a:spcBef>
-        <a:buFont typeface="Arial" panose="020B0704020202020204" pitchFamily="34" charset="0"/>
+        <a:buFont typeface="Arial" panose="020B0604020202020204" pitchFamily="34" charset="0"/>
         <a:buChar char="•"/>
         <a:defRPr sz="1800" kern="1200">
           <a:solidFill>
@@ -3086,7 +3086,7 @@
         <a:spcBef>
           <a:spcPts val="500"/>
         </a:spcBef>
-        <a:buFont typeface="Arial" panose="020B0704020202020204" pitchFamily="34" charset="0"/>
+        <a:buFont typeface="Arial" panose="020B0604020202020204" pitchFamily="34" charset="0"/>
         <a:buChar char="•"/>
         <a:defRPr sz="1800" kern="1200">
           <a:solidFill>
@@ -3104,7 +3104,7 @@
         <a:spcBef>
           <a:spcPts val="500"/>
         </a:spcBef>
-        <a:buFont typeface="Arial" panose="020B0704020202020204" pitchFamily="34" charset="0"/>
+        <a:buFont typeface="Arial" panose="020B0604020202020204" pitchFamily="34" charset="0"/>
         <a:buChar char="•"/>
         <a:defRPr sz="1800" kern="1200">
           <a:solidFill>
@@ -3122,7 +3122,7 @@
         <a:spcBef>
           <a:spcPts val="500"/>
         </a:spcBef>
-        <a:buFont typeface="Arial" panose="020B0704020202020204" pitchFamily="34" charset="0"/>
+        <a:buFont typeface="Arial" panose="020B0604020202020204" pitchFamily="34" charset="0"/>
         <a:buChar char="•"/>
         <a:defRPr sz="1800" kern="1200">
           <a:solidFill>
@@ -3140,7 +3140,7 @@
         <a:spcBef>
           <a:spcPts val="500"/>
         </a:spcBef>
-        <a:buFont typeface="Arial" panose="020B0704020202020204" pitchFamily="34" charset="0"/>
+        <a:buFont typeface="Arial" panose="020B0604020202020204" pitchFamily="34" charset="0"/>
         <a:buChar char="•"/>
         <a:defRPr sz="1800" kern="1200">
           <a:solidFill>
@@ -3158,7 +3158,7 @@
         <a:spcBef>
           <a:spcPts val="500"/>
         </a:spcBef>
-        <a:buFont typeface="Arial" panose="020B0704020202020204" pitchFamily="34" charset="0"/>
+        <a:buFont typeface="Arial" panose="020B0604020202020204" pitchFamily="34" charset="0"/>
         <a:buChar char="•"/>
         <a:defRPr sz="1800" kern="1200">
           <a:solidFill>
@@ -3292,55 +3292,6 @@
           <a:chExt cx="0" cy="0"/>
         </a:xfrm>
       </p:grpSpPr>
-      <p:sp>
-        <p:nvSpPr>
-          <p:cNvPr id="11" name="文本框 10"/>
-          <p:cNvSpPr txBox="1"/>
-          <p:nvPr/>
-        </p:nvSpPr>
-        <p:spPr>
-          <a:xfrm>
-            <a:off x="2202815" y="2502535"/>
-            <a:ext cx="7787005" cy="706755"/>
-          </a:xfrm>
-          <a:prstGeom prst="rect">
-            <a:avLst/>
-          </a:prstGeom>
-          <a:noFill/>
-        </p:spPr>
-        <p:txBody>
-          <a:bodyPr wrap="square" rtlCol="0">
-            <a:spAutoFit/>
-          </a:bodyPr>
-          <a:lstStyle/>
-          <a:p>
-            <a:pPr algn="ctr"/>
-            <a:r>
-              <a:rPr lang="en-US" altLang="zh-CN" sz="4000" b="1" dirty="0">
-                <a:solidFill>
-                  <a:schemeClr val="tx1">
-                    <a:lumMod val="65000"/>
-                    <a:lumOff val="35000"/>
-                  </a:schemeClr>
-                </a:solidFill>
-                <a:latin typeface="Calibri" panose="020F0502020204030204" pitchFamily="34" charset="0"/>
-                <a:ea typeface="张海山锐线体2.0" panose="02000000000000000000" pitchFamily="2" charset="-122"/>
-              </a:rPr>
-              <a:t>&lt;Tên đề tài&gt;</a:t>
-            </a:r>
-            <a:endParaRPr lang="en-US" altLang="zh-CN" sz="4000" b="1" dirty="0">
-              <a:solidFill>
-                <a:schemeClr val="tx1">
-                  <a:lumMod val="65000"/>
-                  <a:lumOff val="35000"/>
-                </a:schemeClr>
-              </a:solidFill>
-              <a:latin typeface="Calibri" panose="020F0502020204030204" pitchFamily="34" charset="0"/>
-              <a:ea typeface="张海山锐线体2.0" panose="02000000000000000000" pitchFamily="2" charset="-122"/>
-            </a:endParaRPr>
-          </a:p>
-        </p:txBody>
-      </p:sp>
       <p:pic>
         <p:nvPicPr>
           <p:cNvPr id="4" name="Picture 3" descr="60c8eb869511524f0b00"/>
@@ -3624,7 +3575,7 @@
               </a:lnSpc>
             </a:pPr>
             <a:r>
-              <a:rPr lang="" altLang="en-US" sz="2800" b="1" dirty="0">
+              <a:rPr lang="en-US" altLang="en-US" sz="2800" b="1" dirty="0">
                 <a:solidFill>
                   <a:schemeClr val="tx1">
                     <a:lumMod val="65000"/>
@@ -3795,7 +3746,7 @@
               <a:t>Quản l</a:t>
             </a:r>
             <a:r>
-              <a:rPr lang="" altLang="en-US" sz="2800" b="1" dirty="0">
+              <a:rPr lang="en-US" altLang="en-US" sz="2800" b="1" dirty="0">
                 <a:solidFill>
                   <a:schemeClr val="tx1">
                     <a:lumMod val="65000"/>
@@ -3966,7 +3917,7 @@
               <a:t>Kiểm thử và xử l</a:t>
             </a:r>
             <a:r>
-              <a:rPr lang="" altLang="en-US" sz="2800" b="1" dirty="0">
+              <a:rPr lang="en-US" altLang="en-US" sz="2800" b="1" dirty="0">
                 <a:solidFill>
                   <a:schemeClr val="tx1">
                     <a:lumMod val="65000"/>
@@ -4022,7 +3973,7 @@
               <a:t>Danh sách các Bug dữ liệu </a:t>
             </a:r>
             <a:r>
-              <a:rPr lang="" altLang="en-US" sz="2800" dirty="0">
+              <a:rPr lang="en-US" altLang="en-US" sz="2800" dirty="0">
                 <a:solidFill>
                   <a:schemeClr val="tx1">
                     <a:lumMod val="65000"/>
@@ -4048,7 +3999,7 @@
               <a:t>ã phát hiện và cách nhóm </a:t>
             </a:r>
             <a:r>
-              <a:rPr lang="" altLang="en-US" sz="2800" dirty="0">
+              <a:rPr lang="en-US" altLang="en-US" sz="2800" dirty="0">
                 <a:solidFill>
                   <a:schemeClr val="tx1">
                     <a:lumMod val="65000"/>
@@ -4189,7 +4140,7 @@
               <a:t>Khó kh</a:t>
             </a:r>
             <a:r>
-              <a:rPr lang="" altLang="en-US" sz="2800" b="1" dirty="0">
+              <a:rPr lang="en-US" altLang="en-US" sz="2800" b="1" dirty="0">
                 <a:solidFill>
                   <a:schemeClr val="tx1">
                     <a:lumMod val="65000"/>
@@ -4245,7 +4196,7 @@
               <a:t>Những bài học rút ra về teamwork và xử l</a:t>
             </a:r>
             <a:r>
-              <a:rPr lang="" altLang="en-US" sz="2800" dirty="0">
+              <a:rPr lang="en-US" altLang="en-US" sz="2800" dirty="0">
                 <a:solidFill>
                   <a:schemeClr val="tx1">
                     <a:lumMod val="65000"/>
@@ -4373,7 +4324,7 @@
               </a:lnSpc>
             </a:pPr>
             <a:r>
-              <a:rPr lang="" altLang="en-US" sz="2800" b="1" dirty="0">
+              <a:rPr lang="en-US" altLang="en-US" sz="2800" b="1" dirty="0">
                 <a:solidFill>
                   <a:schemeClr val="tx1">
                     <a:lumMod val="65000"/>
@@ -4429,7 +4380,7 @@
               <a:t>H</a:t>
             </a:r>
             <a:r>
-              <a:rPr lang="" altLang="en-US" sz="2800" dirty="0">
+              <a:rPr lang="en-US" altLang="en-US" sz="2800" dirty="0">
                 <a:solidFill>
                   <a:schemeClr val="tx1">
                     <a:lumMod val="65000"/>
@@ -4455,7 +4406,7 @@
               <a:t>ớng mở rộng dự án (Ví dụ: </a:t>
             </a:r>
             <a:r>
-              <a:rPr lang="" altLang="en-US" sz="2800" dirty="0">
+              <a:rPr lang="en-US" altLang="en-US" sz="2800" dirty="0">
                 <a:solidFill>
                   <a:schemeClr val="tx1">
                     <a:lumMod val="65000"/>
@@ -5040,7 +4991,7 @@
               <a:t>Tên Dataset, quy mô (số l</a:t>
             </a:r>
             <a:r>
-              <a:rPr lang="" altLang="en-US" sz="2800" dirty="0">
+              <a:rPr lang="en-US" altLang="en-US" sz="2800" dirty="0">
                 <a:solidFill>
                   <a:schemeClr val="tx1">
                     <a:lumMod val="65000"/>
@@ -5224,7 +5175,7 @@
               <a:t>Tóm tắt lộ trình 16 buổi: Từ nạp dữ liệu, tiền xử l</a:t>
             </a:r>
             <a:r>
-              <a:rPr lang="" altLang="en-US" sz="2800" dirty="0">
+              <a:rPr lang="en-US" altLang="en-US" sz="2800" dirty="0">
                 <a:solidFill>
                   <a:schemeClr val="tx1">
                     <a:lumMod val="65000"/>
@@ -5250,7 +5201,7 @@
               <a:t> </a:t>
             </a:r>
             <a:r>
-              <a:rPr lang="" altLang="en-US" sz="2800" dirty="0">
+              <a:rPr lang="en-US" altLang="en-US" sz="2800" dirty="0">
                 <a:solidFill>
                   <a:schemeClr val="tx1">
                     <a:lumMod val="65000"/>
@@ -5421,7 +5372,7 @@
               <a:t>Trình bày sơ </a:t>
             </a:r>
             <a:r>
-              <a:rPr lang="" altLang="en-US" sz="2800" dirty="0">
+              <a:rPr lang="en-US" altLang="en-US" sz="2800" dirty="0">
                 <a:solidFill>
                   <a:schemeClr val="tx1">
                     <a:lumMod val="65000"/>
@@ -5592,7 +5543,7 @@
               <a:t>Mô tả cách kết nối các bảng lớn, xử l</a:t>
             </a:r>
             <a:r>
-              <a:rPr lang="" altLang="en-US" sz="2800" dirty="0">
+              <a:rPr lang="en-US" altLang="en-US" sz="2800" dirty="0">
                 <a:solidFill>
                   <a:schemeClr val="tx1">
                     <a:lumMod val="65000"/>
@@ -5618,7 +5569,7 @@
               <a:t> xung </a:t>
             </a:r>
             <a:r>
-              <a:rPr lang="" altLang="en-US" sz="2800" dirty="0">
+              <a:rPr lang="en-US" altLang="en-US" sz="2800" dirty="0">
                 <a:solidFill>
                   <a:schemeClr val="tx1">
                     <a:lumMod val="65000"/>
@@ -5644,7 +5595,7 @@
               <a:t>ột dữ liệu và kỹ thuật tối </a:t>
             </a:r>
             <a:r>
-              <a:rPr lang="" altLang="en-US" sz="2800" dirty="0">
+              <a:rPr lang="en-US" altLang="en-US" sz="2800" dirty="0">
                 <a:solidFill>
                   <a:schemeClr val="tx1">
                     <a:lumMod val="65000"/>
@@ -5785,7 +5736,7 @@
               <a:t>Tiền xử l</a:t>
             </a:r>
             <a:r>
-              <a:rPr lang="" altLang="en-US" sz="2800" b="1" dirty="0">
+              <a:rPr lang="en-US" altLang="en-US" sz="2800" b="1" dirty="0">
                 <a:solidFill>
                   <a:schemeClr val="tx1">
                     <a:lumMod val="65000"/>
@@ -5841,7 +5792,7 @@
               <a:t>Các b</a:t>
             </a:r>
             <a:r>
-              <a:rPr lang="" altLang="en-US" sz="2800" dirty="0">
+              <a:rPr lang="en-US" altLang="en-US" sz="2800" dirty="0">
                 <a:solidFill>
                   <a:schemeClr val="tx1">
                     <a:lumMod val="65000"/>
@@ -5867,7 +5818,7 @@
               <a:t>ớc xử l</a:t>
             </a:r>
             <a:r>
-              <a:rPr lang="" altLang="en-US" sz="2800" dirty="0">
+              <a:rPr lang="en-US" altLang="en-US" sz="2800" dirty="0">
                 <a:solidFill>
                   <a:schemeClr val="tx1">
                     <a:lumMod val="65000"/>
@@ -5893,7 +5844,7 @@
               <a:t> Missing values, Outliers. So sánh dữ liệu tr</a:t>
             </a:r>
             <a:r>
-              <a:rPr lang="" altLang="en-US" sz="2800" dirty="0">
+              <a:rPr lang="en-US" altLang="en-US" sz="2800" dirty="0">
                 <a:solidFill>
                   <a:schemeClr val="tx1">
                     <a:lumMod val="65000"/>
@@ -6064,7 +6015,7 @@
               <a:t>Giới thiệu ít nhất 10 biến phái sinh </a:t>
             </a:r>
             <a:r>
-              <a:rPr lang="" altLang="en-US" sz="2800" dirty="0">
+              <a:rPr lang="en-US" altLang="en-US" sz="2800" dirty="0">
                 <a:solidFill>
                   <a:schemeClr val="tx1">
                     <a:lumMod val="65000"/>
@@ -6090,7 +6041,7 @@
               <a:t>ợc tạo ra từ các bảng quan hệ </a:t>
             </a:r>
             <a:r>
-              <a:rPr lang="" altLang="en-US" sz="2800" dirty="0">
+              <a:rPr lang="en-US" altLang="en-US" sz="2800" dirty="0">
                 <a:solidFill>
                   <a:schemeClr val="tx1">
                     <a:lumMod val="65000"/>
@@ -6116,7 +6067,7 @@
               <a:t>ể t</a:t>
             </a:r>
             <a:r>
-              <a:rPr lang="" altLang="en-US" sz="2800" dirty="0">
+              <a:rPr lang="en-US" altLang="en-US" sz="2800" dirty="0">
                 <a:solidFill>
                   <a:schemeClr val="tx1">
                     <a:lumMod val="65000"/>
@@ -6287,7 +6238,7 @@
               <a:t>Trình bày các biểu </a:t>
             </a:r>
             <a:r>
-              <a:rPr lang="" altLang="en-US" sz="2800" dirty="0">
+              <a:rPr lang="en-US" altLang="en-US" sz="2800" dirty="0">
                 <a:solidFill>
                   <a:schemeClr val="tx1">
                     <a:lumMod val="65000"/>
@@ -6313,7 +6264,7 @@
               <a:t>ồ trực quan hóa những Insight quan trọng nhất tìm </a:t>
             </a:r>
             <a:r>
-              <a:rPr lang="" altLang="en-US" sz="2800" dirty="0">
+              <a:rPr lang="en-US" altLang="en-US" sz="2800" dirty="0">
                 <a:solidFill>
                   <a:schemeClr val="tx1">
                     <a:lumMod val="65000"/>

</xml_diff>